<commit_message>
Fix presentation content disappearing in PowerPoint
The architecture slide drew upward arrows with negative heights, which is
invalid OOXML; PowerPoint repaired the file and dropped content. Arrows now use
a positive height with a vertical flip, and the generator fails the build if
any slide contains negative or NaN geometry.
</commit_message>
<xml_diff>
--- a/presentation/PixelProse_Presentation.pptx
+++ b/presentation/PixelProse_Presentation.pptx
@@ -17638,7 +17638,7 @@
         <p:spPr>
           <a:xfrm>
             <a:off x="2926080" y="2651760"/>
-            <a:ext cx="502920" cy="0"/>
+            <a:ext cx="502920" cy="914"/>
           </a:xfrm>
           <a:prstGeom prst="line">
             <a:avLst/>
@@ -17660,9 +17660,9 @@
           <p:nvPr/>
         </p:nvSpPr>
         <p:spPr>
-          <a:xfrm>
-            <a:off x="2926080" y="3886200"/>
-            <a:ext cx="502920" cy="-594360"/>
+          <a:xfrm flipV="1">
+            <a:off x="2926080" y="3291840"/>
+            <a:ext cx="502920" cy="594360"/>
           </a:xfrm>
           <a:prstGeom prst="line">
             <a:avLst/>
@@ -17686,7 +17686,7 @@
         <p:spPr>
           <a:xfrm>
             <a:off x="5806440" y="2423160"/>
-            <a:ext cx="502920" cy="0"/>
+            <a:ext cx="502920" cy="914"/>
           </a:xfrm>
           <a:prstGeom prst="line">
             <a:avLst/>
@@ -17710,7 +17710,7 @@
         <p:spPr>
           <a:xfrm>
             <a:off x="5806440" y="3291840"/>
-            <a:ext cx="502920" cy="0"/>
+            <a:ext cx="502920" cy="914"/>
           </a:xfrm>
           <a:prstGeom prst="line">
             <a:avLst/>
@@ -17756,9 +17756,9 @@
           <p:nvPr/>
         </p:nvSpPr>
         <p:spPr>
-          <a:xfrm>
-            <a:off x="8686800" y="5029200"/>
-            <a:ext cx="502920" cy="-457200"/>
+          <a:xfrm flipV="1">
+            <a:off x="8686800" y="4572000"/>
+            <a:ext cx="502920" cy="457200"/>
           </a:xfrm>
           <a:prstGeom prst="line">
             <a:avLst/>
@@ -17780,9 +17780,9 @@
           <p:nvPr/>
         </p:nvSpPr>
         <p:spPr>
-          <a:xfrm>
-            <a:off x="8686800" y="5029200"/>
-            <a:ext cx="502920" cy="-1280160"/>
+          <a:xfrm flipV="1">
+            <a:off x="8686800" y="3749040"/>
+            <a:ext cx="502920" cy="1280160"/>
           </a:xfrm>
           <a:prstGeom prst="line">
             <a:avLst/>
@@ -17804,9 +17804,9 @@
           <p:nvPr/>
         </p:nvSpPr>
         <p:spPr>
-          <a:xfrm>
-            <a:off x="8686800" y="5029200"/>
-            <a:ext cx="502920" cy="-2103120"/>
+          <a:xfrm flipV="1">
+            <a:off x="8686800" y="2926080"/>
+            <a:ext cx="502920" cy="2103120"/>
           </a:xfrm>
           <a:prstGeom prst="line">
             <a:avLst/>
@@ -17828,9 +17828,9 @@
           <p:nvPr/>
         </p:nvSpPr>
         <p:spPr>
-          <a:xfrm>
-            <a:off x="8686800" y="5029200"/>
-            <a:ext cx="502920" cy="-2606040"/>
+          <a:xfrm flipV="1">
+            <a:off x="8686800" y="2423160"/>
+            <a:ext cx="502920" cy="2606040"/>
           </a:xfrm>
           <a:prstGeom prst="line">
             <a:avLst/>

</xml_diff>

<commit_message>
Add Major Project-B report in the KJSIT format
79-page report (Word + PDF) following the institute template: covers,
certificate, approval, declaration, acknowledgement, abstract, contents, lists
of figures/tables/abbreviations, eight chapters, references and attachment
pages. Includes PlantUML sources for all UML diagrams, generated figures and
charts from the real benchmark data, and a two-pass generator that fills in
page numbers.
</commit_message>
<xml_diff>
--- a/presentation/PixelProse_Presentation.pptx
+++ b/presentation/PixelProse_Presentation.pptx
@@ -1415,7 +1415,7 @@
             <a:r>
               <a:rPr lang="en-US" dirty="0"/>
               <a:t>SPEAKER: Kushal Soni  (~40 s)
-Our stack: Python, PyTorch and Hugging Face Transformers for the AI; FastAPI and Uvicorn for the server; Pillow for image processing; plain HTML, CSS and JavaScript for the interface, using the Canvas API for heatmaps and the Web Speech API for text-to-speech; and pytest for 35 automated tests. The neural networks are mocked in the tests, so the whole suite runs in about five seconds.
+Our stack: Python, PyTorch and Hugging Face Transformers for the AI; FastAPI and Uvicorn for the server; Pillow for image processing; plain HTML, CSS and JavaScript for the interface, using the Canvas API for heatmaps and the Web Speech API for text-to-speech; and pytest for 36 automated tests. The neural networks are mocked in the tests, so the whole suite runs in about five seconds.
 In total: four transformer models with about 1.25 billion parameters, eight REST endpoints and 22 features.</a:t>
             </a:r>
             <a:endParaRPr lang="en-US" dirty="0"/>
@@ -10978,7 +10978,7 @@
                 <a:ea typeface="Calibri" pitchFamily="34" charset="-122"/>
                 <a:cs typeface="Calibri" pitchFamily="34" charset="-120"/>
               </a:rPr>
-              <a:t>35 tests, models mocked</a:t>
+              <a:t>36 tests, models mocked</a:t>
             </a:r>
             <a:endParaRPr lang="en-US" sz="1100" dirty="0"/>
           </a:p>
@@ -11473,7 +11473,7 @@
                 <a:ea typeface="Arial" pitchFamily="34" charset="-122"/>
                 <a:cs typeface="Arial" pitchFamily="34" charset="-120"/>
               </a:rPr>
-              <a:t>35</a:t>
+              <a:t>36</a:t>
             </a:r>
             <a:endParaRPr lang="en-US" sz="2800" dirty="0"/>
           </a:p>

</xml_diff>